<commit_message>
Module 9: chapter corrections (snapshot 0061), lectures 9.2-9.3 rebuilt, Lab 9 handout fixes, legacy lab removed
</commit_message>
<xml_diff>
--- a/spatial_cognition/spatial_cognition_lecture_2.pptx
+++ b/spatial_cognition/spatial_cognition_lecture_2.pptx
@@ -999,7 +999,7 @@
           <a:lstStyle/>
           <a:p>
             <a:r>
-              <a:t>Robots face the problem of finding the way too. A robot needs a map to know where it is, and it needs to know where it is to add what it sees to the map. Doing both at once is **simultaneous localization and mapping**, or **SLAM**. A robot keeps a running estimate of its position from its own wheels, and the estimate drifts. When it recognizes a place it has been before, it pulls the whole loop of its path back into line, which is called loop closure. The parallel to correcting a running sum with a landmark is direct.</a:t>
+              <a:t>Robots face the problem of finding the way too. A robot needs a map to estimate its position, and it needs its position to add what it sees to the map. Doing both at once is **simultaneous localization and mapping**, or **SLAM**. A robot keeps a running estimate of its position from its own wheels, and the estimate drifts. When it recognizes a place it has been before, it pulls the whole loop of its path back into line, which is called loop closure. The parallel to correcting a running sum with a landmark is direct.</a:t>
             </a:r>
           </a:p>
           <a:p/>
@@ -1011,7 +1011,7 @@
           <a:p/>
           <a:p>
             <a:r>
-              <a:t>Networks trained to keep track of their own position are a second line of work. In one study, a network trained on its own movement developed some units that fired in repeating triangular patterns. These were like the repeating codes we described for keeping track of position on a map. An agent using the network took shortcuts through newly opened passages. But later researchers trained more than 11,000 networks the same way. Units with triangular patterns appeared only when the training targets were coded in a particular way, chosen with the brain’s grid cells already in mind. So the result shows that such a code can serve an artificial agent. It does not show that training on self-motion produces the code, or that brains have it for that reason.</a:t>
+              <a:t>Networks trained to keep track of their own position are a second line of work. In one study, a network trained on its own movement developed some units that fired in repeating triangular patterns. These were like the repeating codes we described for keeping track of position on a map. An agent using the network took shortcuts through newly opened passages. But later researchers trained more than 11,000 networks the same way. Units with triangular patterns appeared only when the training targets were coded in a particular way, chosen with the brain’s grid cells already in mind. So we can conclude that such a code can serve an artificial agent. We cannot conclude that training on self-motion produces the code, or that brains have it for that reason.</a:t>
             </a:r>
           </a:p>
           <a:p/>
@@ -1452,7 +1452,7 @@
           <a:p/>
           <a:p>
             <a:r>
-              <a:t>The second is resetting. A recognized landmark can replace a drifting estimate outright, especially an estimate of heading. The estimate drifts, and its uncertainty grows, until a familiar log comes into view and the estimate snaps back.</a:t>
+              <a:t>The second is resetting. A recognized landmark can replace a drifting estimate outright, especially an estimate of heading. The estimate drifts further from the true path, until a familiar log comes into view and the estimate snaps back.</a:t>
             </a:r>
           </a:p>
           <a:p/>
@@ -1728,7 +1728,7 @@
           <a:p/>
           <a:p>
             <a:r>
-              <a:t>On the current view, which cue an animal relies on depends on how reliable and noticeable that cue has proved. And unlike the averaging we described for correcting the sum, people in reorientation seem to select the most useful cue rather than average several.</a:t>
+              <a:t>On the current view, which cue an animal relies on depends on how reliable and noticeable that cue has proved. In reorientation, people seem to select the most useful cue rather than average several. That is closer to following one source, the third way of correcting the sum, than to averaging.</a:t>
             </a:r>
           </a:p>
         </p:txBody>

</xml_diff>